<commit_message>
Slides: QR codes for Merit setup (Module 2) and the Appreciative Advising Inventory (Module 5)
Co-Authored-By: Claude Opus 5.5 <noreply@anthropic.com>
Claude-Session: https://claude.ai/code/session_01ScysB3hpFWQZ6JoQjpf1xs
</commit_message>
<xml_diff>
--- a/downloads/slides/FYE100-Module02-Instructor-Slides.pptx
+++ b/downloads/slides/FYE100-Module02-Instructor-Slides.pptx
@@ -118,18 +118,18 @@
   <p:extLst>
     <p:ext uri="{521415D9-36F7-43E2-AB2F-B90AF26B5E84}">
       <p14:sectionLst xmlns:p14="http://schemas.microsoft.com/office/powerpoint/2010/main">
-        <p14:section name="Opening" id="{ed646038-568c-01f3-fd89-6c8ef74e090c}">
+        <p14:section name="Opening" id="{39c71c03-c54d-dd5b-03fa-35ff307117d0}">
           <p14:sldIdLst>
             <p14:sldId id="256"/>
             <p14:sldId id="257"/>
           </p14:sldIdLst>
         </p14:section>
-        <p14:section name="This week" id="{13a1f39d-19e6-ea17-eeb5-814e463a4f0d}">
+        <p14:section name="This week" id="{20202b9b-4c25-435e-26f4-739881224989}">
           <p14:sldIdLst>
             <p14:sldId id="258"/>
           </p14:sldIdLst>
         </p14:section>
-        <p14:section name="Lessons" id="{75494452-7835-61b0-716b-32fc60590727}">
+        <p14:section name="Lessons" id="{ab1f800a-fa38-2594-2e21-a02f847d7fef}">
           <p14:sldIdLst>
             <p14:sldId id="259"/>
             <p14:sldId id="260"/>
@@ -139,13 +139,13 @@
             <p14:sldId id="264"/>
           </p14:sldIdLst>
         </p14:section>
-        <p14:section name="This week's work" id="{3e4519d1-6d72-7d10-598b-617da35f4668}">
+        <p14:section name="This week's work" id="{e64fbb4f-67a6-fbed-72dc-4869b5144659}">
           <p14:sldIdLst>
             <p14:sldId id="265"/>
             <p14:sldId id="266"/>
           </p14:sldIdLst>
         </p14:section>
-        <p14:section name="Discussion" id="{52a93c76-33f5-02d8-24fc-54047ab518db}">
+        <p14:section name="Discussion" id="{dcd743ee-3541-54f7-7547-8e36575cef8b}">
           <p14:sldIdLst>
             <p14:sldId id="267"/>
           </p14:sldIdLst>
@@ -645,7 +645,7 @@
             <a:r>
               <a:rPr lang="en-US" dirty="0"/>
               <a:t>Everything is due Monday by 11:59 PM Central.
-Tasks #1 and #2 are quick: claim your Merit page and share the link, and find your Success Coach's name and contact information.
+Tasks #1 and #2 are quick: claim your Merit page and share the link, and find your Success Coach's name and contact information. Scan the code on this slide to open Merit.
 The AI Chat, Who Has Your Back?, is a conversation with Coach Pathfinder about your support network. Plan for 10 to 15 minutes. It's in the ENGAGE area.
 The Mile Marker is the big one, and it's next.
 In-person sections: today's attendance point counts too.</a:t>
@@ -2678,7 +2678,7 @@
       </p:sp>
       <p:sp>
         <p:nvSpPr>
-          <p:cNvPr id="4" name="Decorative: assignment row">
+          <p:cNvPr id="4" name="Decorative: QR panel">
             <a:extLst>
               <a:ext uri="{C183D7F6-B498-43B3-948B-1728B52AA6E4}">
                 <adec:decorative xmlns:adec="http://schemas.microsoft.com/office/drawing/2017/decorative" val="1"/>
@@ -2690,8 +2690,177 @@
         </p:nvSpPr>
         <p:spPr>
           <a:xfrm>
+            <a:off x="8534095" y="1874520"/>
+            <a:ext cx="3108960" cy="3977640"/>
+          </a:xfrm>
+          <a:prstGeom prst="roundRect">
+            <a:avLst>
+              <a:gd name="adj" fmla="val 3529"/>
+            </a:avLst>
+          </a:prstGeom>
+          <a:solidFill>
+            <a:srgbClr val="FFF5DC"/>
+          </a:solidFill>
+          <a:ln w="12700">
+            <a:solidFill>
+              <a:srgbClr val="FFF5DC"/>
+            </a:solidFill>
+            <a:prstDash val="solid"/>
+          </a:ln>
+          <a:effectLst>
+            <a:outerShdw sx="100000" sy="100000" kx="0" ky="0" algn="bl" rotWithShape="0" blurRad="101600" dist="25400" dir="5400000">
+              <a:srgbClr val="000000">
+                <a:alpha val="12000"/>
+              </a:srgbClr>
+            </a:outerShdw>
+          </a:effectLst>
+        </p:spPr>
+      </p:sp>
+      <p:sp>
+        <p:nvSpPr>
+          <p:cNvPr id="5" name="Text 3"/>
+          <p:cNvSpPr txBox="1"/>
+          <p:nvPr/>
+        </p:nvSpPr>
+        <p:spPr>
+          <a:xfrm>
+            <a:off x="8762695" y="2011680"/>
+            <a:ext cx="2651760" cy="685800"/>
+          </a:xfrm>
+          <a:prstGeom prst="rect">
+            <a:avLst/>
+          </a:prstGeom>
+          <a:noFill/>
+          <a:ln/>
+        </p:spPr>
+        <p:txBody>
+          <a:bodyPr wrap="square" lIns="0" tIns="0" rIns="0" bIns="0" rtlCol="0" anchor="ctr"/>
+          <a:lstStyle/>
+          <a:p>
+            <a:pPr algn="ctr" indent="0" marL="0">
+              <a:buNone/>
+            </a:pPr>
+            <a:r>
+              <a:rPr lang="en-US" sz="2000" b="1" dirty="0">
+                <a:solidFill>
+                  <a:schemeClr val="tx2"/>
+                </a:solidFill>
+              </a:rPr>
+              <a:t>Scan to set up Merit</a:t>
+            </a:r>
+            <a:endParaRPr lang="en-US" sz="2000" dirty="0"/>
+          </a:p>
+        </p:txBody>
+      </p:sp>
+      <p:sp>
+        <p:nvSpPr>
+          <p:cNvPr id="6" name="Decorative: QR frame">
+            <a:extLst>
+              <a:ext uri="{C183D7F6-B498-43B3-948B-1728B52AA6E4}">
+                <adec:decorative xmlns:adec="http://schemas.microsoft.com/office/drawing/2017/decorative" val="1"/>
+              </a:ext>
+            </a:extLst>
+          </p:cNvPr>
+          <p:cNvSpPr/>
+          <p:nvPr/>
+        </p:nvSpPr>
+        <p:spPr>
+          <a:xfrm>
+            <a:off x="8973007" y="2679192"/>
+            <a:ext cx="2231136" cy="2231136"/>
+          </a:xfrm>
+          <a:prstGeom prst="roundRect">
+            <a:avLst>
+              <a:gd name="adj" fmla="val 4098"/>
+            </a:avLst>
+          </a:prstGeom>
+          <a:solidFill>
+            <a:srgbClr val="FFFFFF"/>
+          </a:solidFill>
+          <a:ln w="12700">
+            <a:solidFill>
+              <a:srgbClr val="D9E2EA"/>
+            </a:solidFill>
+            <a:prstDash val="solid"/>
+          </a:ln>
+        </p:spPr>
+      </p:sp>
+      <p:pic>
+        <p:nvPicPr>
+          <p:cNvPr id="7" name="QR code: Scan to set up Merit" descr="QR code for Scan to set up Merit: https://owensboro-kctcs.meritpages.com/">    </p:cNvPr>
+          <p:cNvPicPr>
+            <a:picLocks noChangeAspect="1"/>
+          </p:cNvPicPr>
+          <p:nvPr/>
+        </p:nvPicPr>
+        <p:blipFill>
+          <a:blip r:embed="rId1"/>
+          <a:stretch>
+            <a:fillRect/>
+          </a:stretch>
+        </p:blipFill>
+        <p:spPr>
+          <a:xfrm>
+            <a:off x="9082735" y="2788920"/>
+            <a:ext cx="2011680" cy="2011680"/>
+          </a:xfrm>
+          <a:prstGeom prst="rect">
+            <a:avLst/>
+          </a:prstGeom>
+        </p:spPr>
+      </p:pic>
+      <p:sp>
+        <p:nvSpPr>
+          <p:cNvPr id="8" name="Address: Scan to set up Merit"/>
+          <p:cNvSpPr txBox="1"/>
+          <p:nvPr/>
+        </p:nvSpPr>
+        <p:spPr>
+          <a:xfrm>
+            <a:off x="8534095" y="4937760"/>
+            <a:ext cx="3108960" cy="731520"/>
+          </a:xfrm>
+          <a:prstGeom prst="rect">
+            <a:avLst/>
+          </a:prstGeom>
+          <a:noFill/>
+          <a:ln/>
+        </p:spPr>
+        <p:txBody>
+          <a:bodyPr wrap="square" lIns="0" tIns="0" rIns="0" bIns="0" rtlCol="0" anchor="t"/>
+          <a:lstStyle/>
+          <a:p>
+            <a:pPr algn="ctr" indent="0" marL="0">
+              <a:buNone/>
+            </a:pPr>
+            <a:r>
+              <a:rPr lang="en-US" sz="2000" dirty="0">
+                <a:solidFill>
+                  <a:schemeClr val="accent6"/>
+                </a:solidFill>
+              </a:rPr>
+              <a:t>owensboro-kctcs.meritpages.com</a:t>
+            </a:r>
+            <a:endParaRPr lang="en-US" sz="2000" dirty="0"/>
+          </a:p>
+        </p:txBody>
+      </p:sp>
+      <p:sp>
+        <p:nvSpPr>
+          <p:cNvPr id="9" name="Decorative: assignment row">
+            <a:extLst>
+              <a:ext uri="{C183D7F6-B498-43B3-948B-1728B52AA6E4}">
+                <adec:decorative xmlns:adec="http://schemas.microsoft.com/office/drawing/2017/decorative" val="1"/>
+              </a:ext>
+            </a:extLst>
+          </p:cNvPr>
+          <p:cNvSpPr/>
+          <p:nvPr/>
+        </p:nvSpPr>
+        <p:spPr>
+          <a:xfrm>
             <a:off x="548640" y="1874520"/>
-            <a:ext cx="11094415" cy="841248"/>
+            <a:ext cx="7665415" cy="841248"/>
           </a:xfrm>
           <a:prstGeom prst="roundRect">
             <a:avLst>
@@ -2718,7 +2887,7 @@
       </p:sp>
       <p:sp>
         <p:nvSpPr>
-          <p:cNvPr id="5" name="Decorative: icon circle">
+          <p:cNvPr id="10" name="Decorative: icon circle">
             <a:extLst>
               <a:ext uri="{C183D7F6-B498-43B3-948B-1728B52AA6E4}">
                 <adec:decorative xmlns:adec="http://schemas.microsoft.com/office/drawing/2017/decorative" val="1"/>
@@ -2749,7 +2918,7 @@
       </p:sp>
       <p:pic>
         <p:nvPicPr>
-          <p:cNvPr id="6" name="Decorative: LuAward">
+          <p:cNvPr id="11" name="Decorative: LuAward">
             <a:extLst>
               <a:ext uri="{C183D7F6-B498-43B3-948B-1728B52AA6E4}">
                 <adec:decorative xmlns:adec="http://schemas.microsoft.com/office/drawing/2017/decorative" val="1"/>
@@ -2762,7 +2931,7 @@
           <p:nvPr/>
         </p:nvPicPr>
         <p:blipFill>
-          <a:blip r:embed="rId1"/>
+          <a:blip r:embed="rId2"/>
           <a:stretch>
             <a:fillRect/>
           </a:stretch>
@@ -2779,14 +2948,14 @@
       </p:pic>
       <p:sp>
         <p:nvSpPr>
-          <p:cNvPr id="7" name="Text 4"/>
+          <p:cNvPr id="12" name="Text 8"/>
           <p:cNvSpPr txBox="1"/>
           <p:nvPr/>
         </p:nvSpPr>
         <p:spPr>
           <a:xfrm>
             <a:off x="1508760" y="1929384"/>
-            <a:ext cx="9814255" cy="731520"/>
+            <a:ext cx="6385255" cy="731520"/>
           </a:xfrm>
           <a:prstGeom prst="rect">
             <a:avLst/>
@@ -2829,7 +2998,7 @@
       </p:sp>
       <p:sp>
         <p:nvSpPr>
-          <p:cNvPr id="8" name="Decorative: assignment row">
+          <p:cNvPr id="13" name="Decorative: assignment row">
             <a:extLst>
               <a:ext uri="{C183D7F6-B498-43B3-948B-1728B52AA6E4}">
                 <adec:decorative xmlns:adec="http://schemas.microsoft.com/office/drawing/2017/decorative" val="1"/>
@@ -2842,7 +3011,7 @@
         <p:spPr>
           <a:xfrm>
             <a:off x="548640" y="2880360"/>
-            <a:ext cx="11094415" cy="841248"/>
+            <a:ext cx="7665415" cy="841248"/>
           </a:xfrm>
           <a:prstGeom prst="roundRect">
             <a:avLst>
@@ -2869,7 +3038,7 @@
       </p:sp>
       <p:sp>
         <p:nvSpPr>
-          <p:cNvPr id="9" name="Decorative: icon circle">
+          <p:cNvPr id="14" name="Decorative: icon circle">
             <a:extLst>
               <a:ext uri="{C183D7F6-B498-43B3-948B-1728B52AA6E4}">
                 <adec:decorative xmlns:adec="http://schemas.microsoft.com/office/drawing/2017/decorative" val="1"/>
@@ -2900,7 +3069,7 @@
       </p:sp>
       <p:pic>
         <p:nvPicPr>
-          <p:cNvPr id="10" name="Decorative: LuCompass">
+          <p:cNvPr id="15" name="Decorative: LuCompass">
             <a:extLst>
               <a:ext uri="{C183D7F6-B498-43B3-948B-1728B52AA6E4}">
                 <adec:decorative xmlns:adec="http://schemas.microsoft.com/office/drawing/2017/decorative" val="1"/>
@@ -2913,7 +3082,7 @@
           <p:nvPr/>
         </p:nvPicPr>
         <p:blipFill>
-          <a:blip r:embed="rId2"/>
+          <a:blip r:embed="rId3"/>
           <a:stretch>
             <a:fillRect/>
           </a:stretch>
@@ -2930,14 +3099,14 @@
       </p:pic>
       <p:sp>
         <p:nvSpPr>
-          <p:cNvPr id="11" name="Text 7"/>
+          <p:cNvPr id="16" name="Text 11"/>
           <p:cNvSpPr txBox="1"/>
           <p:nvPr/>
         </p:nvSpPr>
         <p:spPr>
           <a:xfrm>
             <a:off x="1508760" y="2935224"/>
-            <a:ext cx="9814255" cy="731520"/>
+            <a:ext cx="6385255" cy="731520"/>
           </a:xfrm>
           <a:prstGeom prst="rect">
             <a:avLst/>
@@ -2980,7 +3149,7 @@
       </p:sp>
       <p:sp>
         <p:nvSpPr>
-          <p:cNvPr id="12" name="Decorative: assignment row">
+          <p:cNvPr id="17" name="Decorative: assignment row">
             <a:extLst>
               <a:ext uri="{C183D7F6-B498-43B3-948B-1728B52AA6E4}">
                 <adec:decorative xmlns:adec="http://schemas.microsoft.com/office/drawing/2017/decorative" val="1"/>
@@ -2993,7 +3162,7 @@
         <p:spPr>
           <a:xfrm>
             <a:off x="548640" y="3886200"/>
-            <a:ext cx="11094415" cy="841248"/>
+            <a:ext cx="7665415" cy="841248"/>
           </a:xfrm>
           <a:prstGeom prst="roundRect">
             <a:avLst>
@@ -3020,7 +3189,7 @@
       </p:sp>
       <p:sp>
         <p:nvSpPr>
-          <p:cNvPr id="13" name="Decorative: icon circle">
+          <p:cNvPr id="18" name="Decorative: icon circle">
             <a:extLst>
               <a:ext uri="{C183D7F6-B498-43B3-948B-1728B52AA6E4}">
                 <adec:decorative xmlns:adec="http://schemas.microsoft.com/office/drawing/2017/decorative" val="1"/>
@@ -3051,7 +3220,7 @@
       </p:sp>
       <p:pic>
         <p:nvPicPr>
-          <p:cNvPr id="14" name="Decorative: LuBot">
+          <p:cNvPr id="19" name="Decorative: LuBot">
             <a:extLst>
               <a:ext uri="{C183D7F6-B498-43B3-948B-1728B52AA6E4}">
                 <adec:decorative xmlns:adec="http://schemas.microsoft.com/office/drawing/2017/decorative" val="1"/>
@@ -3064,7 +3233,7 @@
           <p:nvPr/>
         </p:nvPicPr>
         <p:blipFill>
-          <a:blip r:embed="rId3"/>
+          <a:blip r:embed="rId4"/>
           <a:stretch>
             <a:fillRect/>
           </a:stretch>
@@ -3081,14 +3250,14 @@
       </p:pic>
       <p:sp>
         <p:nvSpPr>
-          <p:cNvPr id="15" name="Text 10"/>
+          <p:cNvPr id="20" name="Text 14"/>
           <p:cNvSpPr txBox="1"/>
           <p:nvPr/>
         </p:nvSpPr>
         <p:spPr>
           <a:xfrm>
             <a:off x="1508760" y="3941064"/>
-            <a:ext cx="9814255" cy="731520"/>
+            <a:ext cx="6385255" cy="731520"/>
           </a:xfrm>
           <a:prstGeom prst="rect">
             <a:avLst/>
@@ -3131,7 +3300,7 @@
       </p:sp>
       <p:sp>
         <p:nvSpPr>
-          <p:cNvPr id="16" name="Decorative: assignment row">
+          <p:cNvPr id="21" name="Decorative: assignment row">
             <a:extLst>
               <a:ext uri="{C183D7F6-B498-43B3-948B-1728B52AA6E4}">
                 <adec:decorative xmlns:adec="http://schemas.microsoft.com/office/drawing/2017/decorative" val="1"/>
@@ -3144,7 +3313,7 @@
         <p:spPr>
           <a:xfrm>
             <a:off x="548640" y="4892040"/>
-            <a:ext cx="11094415" cy="841248"/>
+            <a:ext cx="7665415" cy="841248"/>
           </a:xfrm>
           <a:prstGeom prst="roundRect">
             <a:avLst>
@@ -3171,7 +3340,7 @@
       </p:sp>
       <p:sp>
         <p:nvSpPr>
-          <p:cNvPr id="17" name="Decorative: icon circle">
+          <p:cNvPr id="22" name="Decorative: icon circle">
             <a:extLst>
               <a:ext uri="{C183D7F6-B498-43B3-948B-1728B52AA6E4}">
                 <adec:decorative xmlns:adec="http://schemas.microsoft.com/office/drawing/2017/decorative" val="1"/>
@@ -3202,7 +3371,7 @@
       </p:sp>
       <p:pic>
         <p:nvPicPr>
-          <p:cNvPr id="18" name="Decorative: LuFlag">
+          <p:cNvPr id="23" name="Decorative: LuFlag">
             <a:extLst>
               <a:ext uri="{C183D7F6-B498-43B3-948B-1728B52AA6E4}">
                 <adec:decorative xmlns:adec="http://schemas.microsoft.com/office/drawing/2017/decorative" val="1"/>
@@ -3215,7 +3384,7 @@
           <p:nvPr/>
         </p:nvPicPr>
         <p:blipFill>
-          <a:blip r:embed="rId4"/>
+          <a:blip r:embed="rId5"/>
           <a:stretch>
             <a:fillRect/>
           </a:stretch>
@@ -3232,14 +3401,14 @@
       </p:pic>
       <p:sp>
         <p:nvSpPr>
-          <p:cNvPr id="19" name="Text 13"/>
+          <p:cNvPr id="24" name="Text 17"/>
           <p:cNvSpPr txBox="1"/>
           <p:nvPr/>
         </p:nvSpPr>
         <p:spPr>
           <a:xfrm>
             <a:off x="1508760" y="4946904"/>
-            <a:ext cx="9814255" cy="731520"/>
+            <a:ext cx="6385255" cy="731520"/>
           </a:xfrm>
           <a:prstGeom prst="rect">
             <a:avLst/>

</xml_diff>